<commit_message>
fix the last training
</commit_message>
<xml_diff>
--- a/deep-learning-from-scratch-5/notebooks/chap6.pptx
+++ b/deep-learning-from-scratch-5/notebooks/chap6.pptx
@@ -3652,10 +3652,16 @@
           <a:p>
             <a:pPr algn="ctr"/>
             <a:r>
-              <a:rPr kumimoji="1" lang="en-US" altLang="ja-JP" b="1" dirty="0"/>
+              <a:rPr kumimoji="1" lang="en-US" altLang="ja-JP" sz="1600" b="1" dirty="0">
+                <a:latin typeface="メイリオ" panose="020B0604030504040204" pitchFamily="50" charset="-128"/>
+                <a:ea typeface="メイリオ" panose="020B0604030504040204" pitchFamily="50" charset="-128"/>
+              </a:rPr>
               <a:t>x</a:t>
             </a:r>
-            <a:endParaRPr kumimoji="1" lang="ja-JP" altLang="en-US" b="1" dirty="0"/>
+            <a:endParaRPr kumimoji="1" lang="ja-JP" altLang="en-US" sz="1600" b="1" dirty="0">
+              <a:latin typeface="メイリオ" panose="020B0604030504040204" pitchFamily="50" charset="-128"/>
+              <a:ea typeface="メイリオ" panose="020B0604030504040204" pitchFamily="50" charset="-128"/>
+            </a:endParaRPr>
           </a:p>
         </p:txBody>
       </p:sp>
@@ -3702,10 +3708,16 @@
           <a:p>
             <a:pPr algn="ctr"/>
             <a:r>
-              <a:rPr lang="en-US" altLang="ja-JP" b="1" dirty="0"/>
-              <a:t>Linear</a:t>
-            </a:r>
-            <a:endParaRPr lang="ja-JP" altLang="en-US" b="1" dirty="0"/>
+              <a:rPr lang="en-US" altLang="ja-JP" sz="1600" b="1" dirty="0">
+                <a:latin typeface="メイリオ" panose="020B0604030504040204" pitchFamily="50" charset="-128"/>
+                <a:ea typeface="メイリオ" panose="020B0604030504040204" pitchFamily="50" charset="-128"/>
+              </a:rPr>
+              <a:t>Linear1</a:t>
+            </a:r>
+            <a:endParaRPr lang="ja-JP" altLang="en-US" sz="1600" b="1" dirty="0">
+              <a:latin typeface="メイリオ" panose="020B0604030504040204" pitchFamily="50" charset="-128"/>
+              <a:ea typeface="メイリオ" panose="020B0604030504040204" pitchFamily="50" charset="-128"/>
+            </a:endParaRPr>
           </a:p>
         </p:txBody>
       </p:sp>
@@ -3752,10 +3764,16 @@
           <a:p>
             <a:pPr algn="ctr"/>
             <a:r>
-              <a:rPr lang="en-US" altLang="ja-JP" b="1" dirty="0"/>
+              <a:rPr lang="en-US" altLang="ja-JP" sz="1600" b="1" dirty="0">
+                <a:latin typeface="メイリオ" panose="020B0604030504040204" pitchFamily="50" charset="-128"/>
+                <a:ea typeface="メイリオ" panose="020B0604030504040204" pitchFamily="50" charset="-128"/>
+              </a:rPr>
               <a:t>Sigmoid</a:t>
             </a:r>
-            <a:endParaRPr lang="ja-JP" altLang="en-US" b="1" dirty="0"/>
+            <a:endParaRPr lang="ja-JP" altLang="en-US" sz="1600" b="1" dirty="0">
+              <a:latin typeface="メイリオ" panose="020B0604030504040204" pitchFamily="50" charset="-128"/>
+              <a:ea typeface="メイリオ" panose="020B0604030504040204" pitchFamily="50" charset="-128"/>
+            </a:endParaRPr>
           </a:p>
         </p:txBody>
       </p:sp>
@@ -3802,10 +3820,16 @@
           <a:p>
             <a:pPr algn="ctr"/>
             <a:r>
-              <a:rPr lang="en-US" altLang="ja-JP" b="1" dirty="0"/>
-              <a:t>Linear</a:t>
-            </a:r>
-            <a:endParaRPr lang="ja-JP" altLang="en-US" b="1" dirty="0"/>
+              <a:rPr lang="en-US" altLang="ja-JP" sz="1600" b="1" dirty="0">
+                <a:latin typeface="メイリオ" panose="020B0604030504040204" pitchFamily="50" charset="-128"/>
+                <a:ea typeface="メイリオ" panose="020B0604030504040204" pitchFamily="50" charset="-128"/>
+              </a:rPr>
+              <a:t>Linear2</a:t>
+            </a:r>
+            <a:endParaRPr lang="ja-JP" altLang="en-US" sz="1600" b="1" dirty="0">
+              <a:latin typeface="メイリオ" panose="020B0604030504040204" pitchFamily="50" charset="-128"/>
+              <a:ea typeface="メイリオ" panose="020B0604030504040204" pitchFamily="50" charset="-128"/>
+            </a:endParaRPr>
           </a:p>
         </p:txBody>
       </p:sp>
@@ -3823,7 +3847,7 @@
         </p:nvSpPr>
         <p:spPr>
           <a:xfrm>
-            <a:off x="4951563" y="2035835"/>
+            <a:off x="5687684" y="2041587"/>
             <a:ext cx="414068" cy="414068"/>
           </a:xfrm>
           <a:prstGeom prst="ellipse">
@@ -3852,10 +3876,16 @@
           <a:p>
             <a:pPr algn="ctr"/>
             <a:r>
-              <a:rPr kumimoji="1" lang="en-US" altLang="ja-JP" b="1" dirty="0"/>
+              <a:rPr kumimoji="1" lang="en-US" altLang="ja-JP" sz="1600" b="1" dirty="0">
+                <a:latin typeface="メイリオ" panose="020B0604030504040204" pitchFamily="50" charset="-128"/>
+                <a:ea typeface="メイリオ" panose="020B0604030504040204" pitchFamily="50" charset="-128"/>
+              </a:rPr>
               <a:t>y</a:t>
             </a:r>
-            <a:endParaRPr kumimoji="1" lang="ja-JP" altLang="en-US" b="1" dirty="0"/>
+            <a:endParaRPr kumimoji="1" lang="ja-JP" altLang="en-US" sz="1600" b="1" dirty="0">
+              <a:latin typeface="メイリオ" panose="020B0604030504040204" pitchFamily="50" charset="-128"/>
+              <a:ea typeface="メイリオ" panose="020B0604030504040204" pitchFamily="50" charset="-128"/>
+            </a:endParaRPr>
           </a:p>
         </p:txBody>
       </p:sp>
@@ -4023,6 +4053,414 @@
           </a:fontRef>
         </p:style>
       </p:cxnSp>
+      <p:sp>
+        <p:nvSpPr>
+          <p:cNvPr id="18" name="正方形/長方形 17">
+            <a:extLst>
+              <a:ext uri="{FF2B5EF4-FFF2-40B4-BE49-F238E27FC236}">
+                <a16:creationId xmlns:a16="http://schemas.microsoft.com/office/drawing/2014/main" id="{47921BCF-036A-B6B5-8C0D-0D63196F4A4E}"/>
+              </a:ext>
+            </a:extLst>
+          </p:cNvPr>
+          <p:cNvSpPr/>
+          <p:nvPr/>
+        </p:nvSpPr>
+        <p:spPr>
+          <a:xfrm>
+            <a:off x="4951563" y="1647646"/>
+            <a:ext cx="322053" cy="1190446"/>
+          </a:xfrm>
+          <a:prstGeom prst="rect">
+            <a:avLst/>
+          </a:prstGeom>
+        </p:spPr>
+        <p:style>
+          <a:lnRef idx="2">
+            <a:schemeClr val="accent2">
+              <a:shade val="15000"/>
+            </a:schemeClr>
+          </a:lnRef>
+          <a:fillRef idx="1">
+            <a:schemeClr val="accent2"/>
+          </a:fillRef>
+          <a:effectRef idx="0">
+            <a:schemeClr val="accent2"/>
+          </a:effectRef>
+          <a:fontRef idx="minor">
+            <a:schemeClr val="lt1"/>
+          </a:fontRef>
+        </p:style>
+        <p:txBody>
+          <a:bodyPr vert="vert270" rtlCol="0" anchor="ctr"/>
+          <a:lstStyle/>
+          <a:p>
+            <a:pPr algn="ctr"/>
+            <a:r>
+              <a:rPr lang="en-US" altLang="ja-JP" sz="1600" b="1" dirty="0" err="1">
+                <a:latin typeface="メイリオ" panose="020B0604030504040204" pitchFamily="50" charset="-128"/>
+                <a:ea typeface="メイリオ" panose="020B0604030504040204" pitchFamily="50" charset="-128"/>
+              </a:rPr>
+              <a:t>Softmax</a:t>
+            </a:r>
+            <a:endParaRPr lang="ja-JP" altLang="en-US" sz="1600" b="1" dirty="0">
+              <a:latin typeface="メイリオ" panose="020B0604030504040204" pitchFamily="50" charset="-128"/>
+              <a:ea typeface="メイリオ" panose="020B0604030504040204" pitchFamily="50" charset="-128"/>
+            </a:endParaRPr>
+          </a:p>
+        </p:txBody>
+      </p:sp>
+      <p:cxnSp>
+        <p:nvCxnSpPr>
+          <p:cNvPr id="20" name="直線矢印コネクタ 19">
+            <a:extLst>
+              <a:ext uri="{FF2B5EF4-FFF2-40B4-BE49-F238E27FC236}">
+                <a16:creationId xmlns:a16="http://schemas.microsoft.com/office/drawing/2014/main" id="{3694C6A2-C843-CF87-8DB3-556E4C7C4730}"/>
+              </a:ext>
+            </a:extLst>
+          </p:cNvPr>
+          <p:cNvCxnSpPr>
+            <a:cxnSpLocks/>
+          </p:cNvCxnSpPr>
+          <p:nvPr/>
+        </p:nvCxnSpPr>
+        <p:spPr>
+          <a:xfrm>
+            <a:off x="5325373" y="2242869"/>
+            <a:ext cx="310551" cy="0"/>
+          </a:xfrm>
+          <a:prstGeom prst="straightConnector1">
+            <a:avLst/>
+          </a:prstGeom>
+          <a:ln w="38100">
+            <a:tailEnd type="triangle"/>
+          </a:ln>
+        </p:spPr>
+        <p:style>
+          <a:lnRef idx="2">
+            <a:schemeClr val="dk1"/>
+          </a:lnRef>
+          <a:fillRef idx="0">
+            <a:schemeClr val="dk1"/>
+          </a:fillRef>
+          <a:effectRef idx="1">
+            <a:schemeClr val="dk1"/>
+          </a:effectRef>
+          <a:fontRef idx="minor">
+            <a:schemeClr val="tx1"/>
+          </a:fontRef>
+        </p:style>
+      </p:cxnSp>
+      <p:sp>
+        <p:nvSpPr>
+          <p:cNvPr id="21" name="テキスト ボックス 20">
+            <a:extLst>
+              <a:ext uri="{FF2B5EF4-FFF2-40B4-BE49-F238E27FC236}">
+                <a16:creationId xmlns:a16="http://schemas.microsoft.com/office/drawing/2014/main" id="{9A73B13C-9AD4-2AF2-D992-28D812E102F9}"/>
+              </a:ext>
+            </a:extLst>
+          </p:cNvPr>
+          <p:cNvSpPr txBox="1"/>
+          <p:nvPr/>
+        </p:nvSpPr>
+        <p:spPr>
+          <a:xfrm>
+            <a:off x="2398144" y="2924297"/>
+            <a:ext cx="966931" cy="261610"/>
+          </a:xfrm>
+          <a:prstGeom prst="rect">
+            <a:avLst/>
+          </a:prstGeom>
+          <a:noFill/>
+        </p:spPr>
+        <p:txBody>
+          <a:bodyPr wrap="none" rtlCol="0">
+            <a:spAutoFit/>
+          </a:bodyPr>
+          <a:lstStyle/>
+          <a:p>
+            <a:r>
+              <a:rPr lang="en-US" altLang="ja-JP" sz="1100" b="1" dirty="0">
+                <a:latin typeface="メイリオ" panose="020B0604030504040204" pitchFamily="50" charset="-128"/>
+                <a:ea typeface="メイリオ" panose="020B0604030504040204" pitchFamily="50" charset="-128"/>
+              </a:rPr>
+              <a:t>100 nodes</a:t>
+            </a:r>
+            <a:endParaRPr kumimoji="1" lang="ja-JP" altLang="en-US" sz="1100" b="1" dirty="0">
+              <a:latin typeface="メイリオ" panose="020B0604030504040204" pitchFamily="50" charset="-128"/>
+              <a:ea typeface="メイリオ" panose="020B0604030504040204" pitchFamily="50" charset="-128"/>
+            </a:endParaRPr>
+          </a:p>
+        </p:txBody>
+      </p:sp>
+      <p:sp>
+        <p:nvSpPr>
+          <p:cNvPr id="22" name="テキスト ボックス 21">
+            <a:extLst>
+              <a:ext uri="{FF2B5EF4-FFF2-40B4-BE49-F238E27FC236}">
+                <a16:creationId xmlns:a16="http://schemas.microsoft.com/office/drawing/2014/main" id="{77CB7ECC-F810-2AC5-68E2-1D2D9385B313}"/>
+              </a:ext>
+            </a:extLst>
+          </p:cNvPr>
+          <p:cNvSpPr txBox="1"/>
+          <p:nvPr/>
+        </p:nvSpPr>
+        <p:spPr>
+          <a:xfrm>
+            <a:off x="3893002" y="2955869"/>
+            <a:ext cx="966931" cy="261610"/>
+          </a:xfrm>
+          <a:prstGeom prst="rect">
+            <a:avLst/>
+          </a:prstGeom>
+          <a:noFill/>
+        </p:spPr>
+        <p:txBody>
+          <a:bodyPr wrap="none" rtlCol="0">
+            <a:spAutoFit/>
+          </a:bodyPr>
+          <a:lstStyle/>
+          <a:p>
+            <a:r>
+              <a:rPr lang="en-US" altLang="ja-JP" sz="1100" b="1" dirty="0">
+                <a:latin typeface="メイリオ" panose="020B0604030504040204" pitchFamily="50" charset="-128"/>
+                <a:ea typeface="メイリオ" panose="020B0604030504040204" pitchFamily="50" charset="-128"/>
+              </a:rPr>
+              <a:t>100 nodes</a:t>
+            </a:r>
+            <a:endParaRPr kumimoji="1" lang="ja-JP" altLang="en-US" sz="1100" b="1" dirty="0">
+              <a:latin typeface="メイリオ" panose="020B0604030504040204" pitchFamily="50" charset="-128"/>
+              <a:ea typeface="メイリオ" panose="020B0604030504040204" pitchFamily="50" charset="-128"/>
+            </a:endParaRPr>
+          </a:p>
+        </p:txBody>
+      </p:sp>
+      <mc:AlternateContent xmlns:mc="http://schemas.openxmlformats.org/markup-compatibility/2006">
+        <mc:Choice xmlns:a14="http://schemas.microsoft.com/office/drawing/2010/main" Requires="a14">
+          <p:sp>
+            <p:nvSpPr>
+              <p:cNvPr id="23" name="テキスト ボックス 22">
+                <a:extLst>
+                  <a:ext uri="{FF2B5EF4-FFF2-40B4-BE49-F238E27FC236}">
+                    <a16:creationId xmlns:a16="http://schemas.microsoft.com/office/drawing/2014/main" id="{45BA7185-640F-ED89-CC20-F702C6A61193}"/>
+                  </a:ext>
+                </a:extLst>
+              </p:cNvPr>
+              <p:cNvSpPr txBox="1"/>
+              <p:nvPr/>
+            </p:nvSpPr>
+            <p:spPr>
+              <a:xfrm>
+                <a:off x="4704560" y="1202844"/>
+                <a:ext cx="816057" cy="444802"/>
+              </a:xfrm>
+              <a:prstGeom prst="rect">
+                <a:avLst/>
+              </a:prstGeom>
+              <a:noFill/>
+            </p:spPr>
+            <p:txBody>
+              <a:bodyPr wrap="none" rtlCol="0">
+                <a:spAutoFit/>
+              </a:bodyPr>
+              <a:lstStyle/>
+              <a:p>
+                <a14:m>
+                  <m:oMathPara xmlns:m="http://schemas.openxmlformats.org/officeDocument/2006/math">
+                    <m:oMathParaPr>
+                      <m:jc m:val="centerGroup"/>
+                    </m:oMathParaPr>
+                    <m:oMath xmlns:m="http://schemas.openxmlformats.org/officeDocument/2006/math">
+                      <m:f>
+                        <m:fPr>
+                          <m:ctrlPr>
+                            <a:rPr kumimoji="1" lang="en-US" altLang="ja-JP" sz="1100" i="1" smtClean="0">
+                              <a:latin typeface="Cambria Math" panose="02040503050406030204" pitchFamily="18" charset="0"/>
+                              <a:ea typeface="メイリオ" panose="020B0604030504040204" pitchFamily="50" charset="-128"/>
+                            </a:rPr>
+                          </m:ctrlPr>
+                        </m:fPr>
+                        <m:num>
+                          <m:r>
+                            <m:rPr>
+                              <m:sty m:val="p"/>
+                            </m:rPr>
+                            <a:rPr kumimoji="1" lang="en-US" altLang="ja-JP" sz="1100" b="0" i="0" smtClean="0">
+                              <a:latin typeface="Cambria Math" panose="02040503050406030204" pitchFamily="18" charset="0"/>
+                              <a:ea typeface="メイリオ" panose="020B0604030504040204" pitchFamily="50" charset="-128"/>
+                            </a:rPr>
+                            <m:t>exp</m:t>
+                          </m:r>
+                          <m:r>
+                            <a:rPr kumimoji="1" lang="en-US" altLang="ja-JP" sz="1100" b="0" i="1" smtClean="0">
+                              <a:latin typeface="Cambria Math" panose="02040503050406030204" pitchFamily="18" charset="0"/>
+                              <a:ea typeface="メイリオ" panose="020B0604030504040204" pitchFamily="50" charset="-128"/>
+                            </a:rPr>
+                            <m:t>⁡(</m:t>
+                          </m:r>
+                          <m:sSub>
+                            <m:sSubPr>
+                              <m:ctrlPr>
+                                <a:rPr kumimoji="1" lang="en-US" altLang="ja-JP" sz="1100" b="0" i="1" smtClean="0">
+                                  <a:latin typeface="Cambria Math" panose="02040503050406030204" pitchFamily="18" charset="0"/>
+                                  <a:ea typeface="メイリオ" panose="020B0604030504040204" pitchFamily="50" charset="-128"/>
+                                </a:rPr>
+                              </m:ctrlPr>
+                            </m:sSubPr>
+                            <m:e>
+                              <m:r>
+                                <a:rPr kumimoji="1" lang="en-US" altLang="ja-JP" sz="1100" b="0" i="1" smtClean="0">
+                                  <a:latin typeface="Cambria Math" panose="02040503050406030204" pitchFamily="18" charset="0"/>
+                                  <a:ea typeface="メイリオ" panose="020B0604030504040204" pitchFamily="50" charset="-128"/>
+                                </a:rPr>
+                                <m:t>𝑎</m:t>
+                              </m:r>
+                            </m:e>
+                            <m:sub>
+                              <m:r>
+                                <a:rPr kumimoji="1" lang="en-US" altLang="ja-JP" sz="1100" b="0" i="1" smtClean="0">
+                                  <a:latin typeface="Cambria Math" panose="02040503050406030204" pitchFamily="18" charset="0"/>
+                                  <a:ea typeface="メイリオ" panose="020B0604030504040204" pitchFamily="50" charset="-128"/>
+                                </a:rPr>
+                                <m:t>𝑖</m:t>
+                              </m:r>
+                            </m:sub>
+                          </m:sSub>
+                          <m:r>
+                            <a:rPr kumimoji="1" lang="en-US" altLang="ja-JP" sz="1100" b="0" i="1" smtClean="0">
+                              <a:latin typeface="Cambria Math" panose="02040503050406030204" pitchFamily="18" charset="0"/>
+                              <a:ea typeface="メイリオ" panose="020B0604030504040204" pitchFamily="50" charset="-128"/>
+                            </a:rPr>
+                            <m:t>)</m:t>
+                          </m:r>
+                        </m:num>
+                        <m:den>
+                          <m:nary>
+                            <m:naryPr>
+                              <m:chr m:val="∑"/>
+                              <m:subHide m:val="on"/>
+                              <m:supHide m:val="on"/>
+                              <m:ctrlPr>
+                                <a:rPr kumimoji="1" lang="en-US" altLang="ja-JP" sz="1100" i="1" smtClean="0">
+                                  <a:latin typeface="Cambria Math" panose="02040503050406030204" pitchFamily="18" charset="0"/>
+                                  <a:ea typeface="メイリオ" panose="020B0604030504040204" pitchFamily="50" charset="-128"/>
+                                </a:rPr>
+                              </m:ctrlPr>
+                            </m:naryPr>
+                            <m:sub/>
+                            <m:sup/>
+                            <m:e>
+                              <m:r>
+                                <m:rPr>
+                                  <m:sty m:val="p"/>
+                                </m:rPr>
+                                <a:rPr kumimoji="1" lang="en-US" altLang="ja-JP" sz="1100" b="0" i="0" smtClean="0">
+                                  <a:latin typeface="Cambria Math" panose="02040503050406030204" pitchFamily="18" charset="0"/>
+                                  <a:ea typeface="メイリオ" panose="020B0604030504040204" pitchFamily="50" charset="-128"/>
+                                </a:rPr>
+                                <m:t>exp</m:t>
+                              </m:r>
+                              <m:r>
+                                <a:rPr kumimoji="1" lang="en-US" altLang="ja-JP" sz="1100" b="0" i="1" smtClean="0">
+                                  <a:latin typeface="Cambria Math" panose="02040503050406030204" pitchFamily="18" charset="0"/>
+                                  <a:ea typeface="メイリオ" panose="020B0604030504040204" pitchFamily="50" charset="-128"/>
+                                </a:rPr>
+                                <m:t>(</m:t>
+                              </m:r>
+                              <m:sSub>
+                                <m:sSubPr>
+                                  <m:ctrlPr>
+                                    <a:rPr kumimoji="1" lang="en-US" altLang="ja-JP" sz="1100" b="0" i="1" smtClean="0">
+                                      <a:latin typeface="Cambria Math" panose="02040503050406030204" pitchFamily="18" charset="0"/>
+                                      <a:ea typeface="メイリオ" panose="020B0604030504040204" pitchFamily="50" charset="-128"/>
+                                    </a:rPr>
+                                  </m:ctrlPr>
+                                </m:sSubPr>
+                                <m:e>
+                                  <m:r>
+                                    <a:rPr kumimoji="1" lang="en-US" altLang="ja-JP" sz="1100" b="0" i="1" smtClean="0">
+                                      <a:latin typeface="Cambria Math" panose="02040503050406030204" pitchFamily="18" charset="0"/>
+                                      <a:ea typeface="メイリオ" panose="020B0604030504040204" pitchFamily="50" charset="-128"/>
+                                    </a:rPr>
+                                    <m:t>𝑎</m:t>
+                                  </m:r>
+                                </m:e>
+                                <m:sub>
+                                  <m:r>
+                                    <a:rPr kumimoji="1" lang="en-US" altLang="ja-JP" sz="1100" b="0" i="1" smtClean="0">
+                                      <a:latin typeface="Cambria Math" panose="02040503050406030204" pitchFamily="18" charset="0"/>
+                                      <a:ea typeface="メイリオ" panose="020B0604030504040204" pitchFamily="50" charset="-128"/>
+                                    </a:rPr>
+                                    <m:t>𝑖</m:t>
+                                  </m:r>
+                                </m:sub>
+                              </m:sSub>
+                              <m:r>
+                                <a:rPr kumimoji="1" lang="en-US" altLang="ja-JP" sz="1100" b="0" i="1" smtClean="0">
+                                  <a:latin typeface="Cambria Math" panose="02040503050406030204" pitchFamily="18" charset="0"/>
+                                  <a:ea typeface="メイリオ" panose="020B0604030504040204" pitchFamily="50" charset="-128"/>
+                                </a:rPr>
+                                <m:t>)</m:t>
+                              </m:r>
+                            </m:e>
+                          </m:nary>
+                        </m:den>
+                      </m:f>
+                    </m:oMath>
+                  </m:oMathPara>
+                </a14:m>
+                <a:endParaRPr kumimoji="1" lang="ja-JP" altLang="en-US" sz="1100" dirty="0">
+                  <a:latin typeface="メイリオ" panose="020B0604030504040204" pitchFamily="50" charset="-128"/>
+                  <a:ea typeface="メイリオ" panose="020B0604030504040204" pitchFamily="50" charset="-128"/>
+                </a:endParaRPr>
+              </a:p>
+            </p:txBody>
+          </p:sp>
+        </mc:Choice>
+        <mc:Fallback>
+          <p:sp>
+            <p:nvSpPr>
+              <p:cNvPr id="23" name="テキスト ボックス 22">
+                <a:extLst>
+                  <a:ext uri="{FF2B5EF4-FFF2-40B4-BE49-F238E27FC236}">
+                    <a16:creationId xmlns:a16="http://schemas.microsoft.com/office/drawing/2014/main" id="{45BA7185-640F-ED89-CC20-F702C6A61193}"/>
+                  </a:ext>
+                </a:extLst>
+              </p:cNvPr>
+              <p:cNvSpPr txBox="1">
+                <a:spLocks noRot="1" noChangeAspect="1" noMove="1" noResize="1" noEditPoints="1" noAdjustHandles="1" noChangeArrowheads="1" noChangeShapeType="1" noTextEdit="1"/>
+              </p:cNvSpPr>
+              <p:nvPr/>
+            </p:nvSpPr>
+            <p:spPr>
+              <a:xfrm>
+                <a:off x="4704560" y="1202844"/>
+                <a:ext cx="816057" cy="444802"/>
+              </a:xfrm>
+              <a:prstGeom prst="rect">
+                <a:avLst/>
+              </a:prstGeom>
+              <a:blipFill>
+                <a:blip r:embed="rId2"/>
+                <a:stretch>
+                  <a:fillRect l="-17910" t="-13699" b="-89041"/>
+                </a:stretch>
+              </a:blipFill>
+            </p:spPr>
+            <p:txBody>
+              <a:bodyPr/>
+              <a:lstStyle/>
+              <a:p>
+                <a:r>
+                  <a:rPr lang="ja-JP" altLang="en-US">
+                    <a:noFill/>
+                  </a:rPr>
+                  <a:t> </a:t>
+                </a:r>
+              </a:p>
+            </p:txBody>
+          </p:sp>
+        </mc:Fallback>
+      </mc:AlternateContent>
     </p:spTree>
     <p:extLst>
       <p:ext uri="{BB962C8B-B14F-4D97-AF65-F5344CB8AC3E}">

</xml_diff>